<commit_message>
Replaced "AlleleID" with "Allele ID" in fig 2b
</commit_message>
<xml_diff>
--- a/figures/fig-2/fig-2.pptx
+++ b/figures/fig-2/fig-2.pptx
@@ -243,7 +243,7 @@
           <a:p>
             <a:fld id="{FE14D9E9-5EC3-D444-8E38-E43C59FC4D54}" type="datetimeFigureOut">
               <a:rPr lang="en-US" smtClean="0"/>
-              <a:t>2/25/26</a:t>
+              <a:t>6/3/26</a:t>
             </a:fld>
             <a:endParaRPr lang="en-US"/>
           </a:p>
@@ -413,7 +413,7 @@
           <a:p>
             <a:fld id="{FE14D9E9-5EC3-D444-8E38-E43C59FC4D54}" type="datetimeFigureOut">
               <a:rPr lang="en-US" smtClean="0"/>
-              <a:t>2/25/26</a:t>
+              <a:t>6/3/26</a:t>
             </a:fld>
             <a:endParaRPr lang="en-US"/>
           </a:p>
@@ -593,7 +593,7 @@
           <a:p>
             <a:fld id="{FE14D9E9-5EC3-D444-8E38-E43C59FC4D54}" type="datetimeFigureOut">
               <a:rPr lang="en-US" smtClean="0"/>
-              <a:t>2/25/26</a:t>
+              <a:t>6/3/26</a:t>
             </a:fld>
             <a:endParaRPr lang="en-US"/>
           </a:p>
@@ -763,7 +763,7 @@
           <a:p>
             <a:fld id="{FE14D9E9-5EC3-D444-8E38-E43C59FC4D54}" type="datetimeFigureOut">
               <a:rPr lang="en-US" smtClean="0"/>
-              <a:t>2/25/26</a:t>
+              <a:t>6/3/26</a:t>
             </a:fld>
             <a:endParaRPr lang="en-US"/>
           </a:p>
@@ -1009,7 +1009,7 @@
           <a:p>
             <a:fld id="{FE14D9E9-5EC3-D444-8E38-E43C59FC4D54}" type="datetimeFigureOut">
               <a:rPr lang="en-US" smtClean="0"/>
-              <a:t>2/25/26</a:t>
+              <a:t>6/3/26</a:t>
             </a:fld>
             <a:endParaRPr lang="en-US"/>
           </a:p>
@@ -1241,7 +1241,7 @@
           <a:p>
             <a:fld id="{FE14D9E9-5EC3-D444-8E38-E43C59FC4D54}" type="datetimeFigureOut">
               <a:rPr lang="en-US" smtClean="0"/>
-              <a:t>2/25/26</a:t>
+              <a:t>6/3/26</a:t>
             </a:fld>
             <a:endParaRPr lang="en-US"/>
           </a:p>
@@ -1608,7 +1608,7 @@
           <a:p>
             <a:fld id="{FE14D9E9-5EC3-D444-8E38-E43C59FC4D54}" type="datetimeFigureOut">
               <a:rPr lang="en-US" smtClean="0"/>
-              <a:t>2/25/26</a:t>
+              <a:t>6/3/26</a:t>
             </a:fld>
             <a:endParaRPr lang="en-US"/>
           </a:p>
@@ -1726,7 +1726,7 @@
           <a:p>
             <a:fld id="{FE14D9E9-5EC3-D444-8E38-E43C59FC4D54}" type="datetimeFigureOut">
               <a:rPr lang="en-US" smtClean="0"/>
-              <a:t>2/25/26</a:t>
+              <a:t>6/3/26</a:t>
             </a:fld>
             <a:endParaRPr lang="en-US"/>
           </a:p>
@@ -1821,7 +1821,7 @@
           <a:p>
             <a:fld id="{FE14D9E9-5EC3-D444-8E38-E43C59FC4D54}" type="datetimeFigureOut">
               <a:rPr lang="en-US" smtClean="0"/>
-              <a:t>2/25/26</a:t>
+              <a:t>6/3/26</a:t>
             </a:fld>
             <a:endParaRPr lang="en-US"/>
           </a:p>
@@ -2098,7 +2098,7 @@
           <a:p>
             <a:fld id="{FE14D9E9-5EC3-D444-8E38-E43C59FC4D54}" type="datetimeFigureOut">
               <a:rPr lang="en-US" smtClean="0"/>
-              <a:t>2/25/26</a:t>
+              <a:t>6/3/26</a:t>
             </a:fld>
             <a:endParaRPr lang="en-US"/>
           </a:p>
@@ -2355,7 +2355,7 @@
           <a:p>
             <a:fld id="{FE14D9E9-5EC3-D444-8E38-E43C59FC4D54}" type="datetimeFigureOut">
               <a:rPr lang="en-US" smtClean="0"/>
-              <a:t>2/25/26</a:t>
+              <a:t>6/3/26</a:t>
             </a:fld>
             <a:endParaRPr lang="en-US"/>
           </a:p>
@@ -2568,7 +2568,7 @@
           <a:p>
             <a:fld id="{FE14D9E9-5EC3-D444-8E38-E43C59FC4D54}" type="datetimeFigureOut">
               <a:rPr lang="en-US" smtClean="0"/>
-              <a:t>2/25/26</a:t>
+              <a:t>6/3/26</a:t>
             </a:fld>
             <a:endParaRPr lang="en-US"/>
           </a:p>
@@ -2979,154 +2979,175 @@
           <a:chExt cx="0" cy="0"/>
         </a:xfrm>
       </p:grpSpPr>
-      <p:pic>
-        <p:nvPicPr>
-          <p:cNvPr id="13" name="Graphic 12">
+      <p:grpSp>
+        <p:nvGrpSpPr>
+          <p:cNvPr id="4" name="Group 3">
             <a:extLst>
               <a:ext uri="{FF2B5EF4-FFF2-40B4-BE49-F238E27FC236}">
-                <a16:creationId xmlns:a16="http://schemas.microsoft.com/office/drawing/2014/main" id="{EFDD7686-13EF-54AE-C6B4-572D6CEBF56D}"/>
+                <a16:creationId xmlns:a16="http://schemas.microsoft.com/office/drawing/2014/main" id="{4C807A00-4699-D0BA-A50F-93DE51C925B2}"/>
               </a:ext>
             </a:extLst>
           </p:cNvPr>
-          <p:cNvPicPr>
-            <a:picLocks noChangeAspect="1"/>
-          </p:cNvPicPr>
+          <p:cNvGrpSpPr/>
           <p:nvPr/>
-        </p:nvPicPr>
-        <p:blipFill>
-          <a:blip r:embed="rId2">
-            <a:extLst>
-              <a:ext uri="{96DAC541-7B7A-43D3-8B79-37D633B846F1}">
-                <asvg:svgBlip xmlns:asvg="http://schemas.microsoft.com/office/drawing/2016/SVG/main" r:embed="rId3"/>
-              </a:ext>
-            </a:extLst>
-          </a:blip>
-          <a:stretch>
-            <a:fillRect/>
-          </a:stretch>
-        </p:blipFill>
-        <p:spPr>
+        </p:nvGrpSpPr>
+        <p:grpSpPr>
           <a:xfrm>
-            <a:off x="4651018" y="-262"/>
-            <a:ext cx="1857981" cy="1710000"/>
+            <a:off x="59187" y="0"/>
+            <a:ext cx="6466149" cy="1710000"/>
+            <a:chOff x="59187" y="0"/>
+            <a:chExt cx="6466149" cy="1710000"/>
           </a:xfrm>
-          <a:prstGeom prst="rect">
-            <a:avLst/>
-          </a:prstGeom>
-        </p:spPr>
-      </p:pic>
-      <p:pic>
-        <p:nvPicPr>
-          <p:cNvPr id="21" name="Graphic 20">
-            <a:extLst>
-              <a:ext uri="{FF2B5EF4-FFF2-40B4-BE49-F238E27FC236}">
-                <a16:creationId xmlns:a16="http://schemas.microsoft.com/office/drawing/2014/main" id="{6BC84858-A1B9-6820-9BE6-29B0DBAC1F6E}"/>
-              </a:ext>
-            </a:extLst>
-          </p:cNvPr>
-          <p:cNvPicPr>
-            <a:picLocks noChangeAspect="1"/>
-          </p:cNvPicPr>
-          <p:nvPr/>
-        </p:nvPicPr>
-        <p:blipFill>
-          <a:blip r:embed="rId4">
-            <a:extLst>
-              <a:ext uri="{96DAC541-7B7A-43D3-8B79-37D633B846F1}">
-                <asvg:svgBlip xmlns:asvg="http://schemas.microsoft.com/office/drawing/2016/SVG/main" r:embed="rId5"/>
-              </a:ext>
-            </a:extLst>
-          </a:blip>
-          <a:stretch>
-            <a:fillRect/>
-          </a:stretch>
-        </p:blipFill>
-        <p:spPr>
-          <a:xfrm>
-            <a:off x="79126" y="0"/>
-            <a:ext cx="4471229" cy="1710000"/>
-          </a:xfrm>
-          <a:prstGeom prst="rect">
-            <a:avLst/>
-          </a:prstGeom>
-        </p:spPr>
-      </p:pic>
-      <p:sp>
-        <p:nvSpPr>
-          <p:cNvPr id="22" name="TextBox 21">
-            <a:extLst>
-              <a:ext uri="{FF2B5EF4-FFF2-40B4-BE49-F238E27FC236}">
-                <a16:creationId xmlns:a16="http://schemas.microsoft.com/office/drawing/2014/main" id="{E2FCDC3B-C9BB-A2AD-FD9F-8646A25BE396}"/>
-              </a:ext>
-            </a:extLst>
-          </p:cNvPr>
-          <p:cNvSpPr txBox="1"/>
-          <p:nvPr/>
-        </p:nvSpPr>
-        <p:spPr>
-          <a:xfrm>
-            <a:off x="59187" y="16470"/>
-            <a:ext cx="242374" cy="215444"/>
-          </a:xfrm>
-          <a:prstGeom prst="rect">
-            <a:avLst/>
-          </a:prstGeom>
-          <a:noFill/>
-        </p:spPr>
-        <p:txBody>
-          <a:bodyPr wrap="none" rtlCol="0">
-            <a:spAutoFit/>
-          </a:bodyPr>
-          <a:lstStyle/>
-          <a:p>
-            <a:r>
-              <a:rPr lang="en-US" sz="800" b="1" dirty="0">
-                <a:latin typeface="Arial" panose="020B0604020202020204" pitchFamily="34" charset="0"/>
-                <a:cs typeface="Arial" panose="020B0604020202020204" pitchFamily="34" charset="0"/>
-              </a:rPr>
-              <a:t>a</a:t>
-            </a:r>
-          </a:p>
-        </p:txBody>
-      </p:sp>
-      <p:sp>
-        <p:nvSpPr>
-          <p:cNvPr id="23" name="TextBox 22">
-            <a:extLst>
-              <a:ext uri="{FF2B5EF4-FFF2-40B4-BE49-F238E27FC236}">
-                <a16:creationId xmlns:a16="http://schemas.microsoft.com/office/drawing/2014/main" id="{751EA6F9-003A-3B7D-8F82-7ABCC356845E}"/>
-              </a:ext>
-            </a:extLst>
-          </p:cNvPr>
-          <p:cNvSpPr txBox="1"/>
-          <p:nvPr/>
-        </p:nvSpPr>
-        <p:spPr>
-          <a:xfrm>
-            <a:off x="4526720" y="12195"/>
-            <a:ext cx="247184" cy="215444"/>
-          </a:xfrm>
-          <a:prstGeom prst="rect">
-            <a:avLst/>
-          </a:prstGeom>
-          <a:noFill/>
-        </p:spPr>
-        <p:txBody>
-          <a:bodyPr wrap="none" rtlCol="0">
-            <a:spAutoFit/>
-          </a:bodyPr>
-          <a:lstStyle/>
-          <a:p>
-            <a:r>
-              <a:rPr lang="en-US" sz="800" b="1" dirty="0">
-                <a:latin typeface="Arial" panose="020B0604020202020204" pitchFamily="34" charset="0"/>
-                <a:cs typeface="Arial" panose="020B0604020202020204" pitchFamily="34" charset="0"/>
-              </a:rPr>
-              <a:t>b</a:t>
-            </a:r>
-          </a:p>
-        </p:txBody>
-      </p:sp>
+        </p:grpSpPr>
+        <p:pic>
+          <p:nvPicPr>
+            <p:cNvPr id="3" name="Graphic 2">
+              <a:extLst>
+                <a:ext uri="{FF2B5EF4-FFF2-40B4-BE49-F238E27FC236}">
+                  <a16:creationId xmlns:a16="http://schemas.microsoft.com/office/drawing/2014/main" id="{D5D0A023-9087-BF64-C107-59E3C890F2BB}"/>
+                </a:ext>
+              </a:extLst>
+            </p:cNvPr>
+            <p:cNvPicPr>
+              <a:picLocks noChangeAspect="1"/>
+            </p:cNvPicPr>
+            <p:nvPr/>
+          </p:nvPicPr>
+          <p:blipFill>
+            <a:blip>
+              <a:extLst>
+                <a:ext uri="{96DAC541-7B7A-43D3-8B79-37D633B846F1}">
+                  <asvg:svgBlip xmlns:asvg="http://schemas.microsoft.com/office/drawing/2016/SVG/main" r:embed="rId2"/>
+                </a:ext>
+              </a:extLst>
+            </a:blip>
+            <a:stretch>
+              <a:fillRect/>
+            </a:stretch>
+          </p:blipFill>
+          <p:spPr>
+            <a:xfrm>
+              <a:off x="4651200" y="0"/>
+              <a:ext cx="1874136" cy="1709738"/>
+            </a:xfrm>
+            <a:prstGeom prst="rect">
+              <a:avLst/>
+            </a:prstGeom>
+          </p:spPr>
+        </p:pic>
+        <p:pic>
+          <p:nvPicPr>
+            <p:cNvPr id="21" name="Graphic 20">
+              <a:extLst>
+                <a:ext uri="{FF2B5EF4-FFF2-40B4-BE49-F238E27FC236}">
+                  <a16:creationId xmlns:a16="http://schemas.microsoft.com/office/drawing/2014/main" id="{6BC84858-A1B9-6820-9BE6-29B0DBAC1F6E}"/>
+                </a:ext>
+              </a:extLst>
+            </p:cNvPr>
+            <p:cNvPicPr>
+              <a:picLocks noChangeAspect="1"/>
+            </p:cNvPicPr>
+            <p:nvPr/>
+          </p:nvPicPr>
+          <p:blipFill>
+            <a:blip>
+              <a:extLst>
+                <a:ext uri="{96DAC541-7B7A-43D3-8B79-37D633B846F1}">
+                  <asvg:svgBlip xmlns:asvg="http://schemas.microsoft.com/office/drawing/2016/SVG/main" r:embed="rId3"/>
+                </a:ext>
+              </a:extLst>
+            </a:blip>
+            <a:stretch>
+              <a:fillRect/>
+            </a:stretch>
+          </p:blipFill>
+          <p:spPr>
+            <a:xfrm>
+              <a:off x="79126" y="0"/>
+              <a:ext cx="4471229" cy="1710000"/>
+            </a:xfrm>
+            <a:prstGeom prst="rect">
+              <a:avLst/>
+            </a:prstGeom>
+          </p:spPr>
+        </p:pic>
+        <p:sp>
+          <p:nvSpPr>
+            <p:cNvPr id="22" name="TextBox 21">
+              <a:extLst>
+                <a:ext uri="{FF2B5EF4-FFF2-40B4-BE49-F238E27FC236}">
+                  <a16:creationId xmlns:a16="http://schemas.microsoft.com/office/drawing/2014/main" id="{E2FCDC3B-C9BB-A2AD-FD9F-8646A25BE396}"/>
+                </a:ext>
+              </a:extLst>
+            </p:cNvPr>
+            <p:cNvSpPr txBox="1"/>
+            <p:nvPr/>
+          </p:nvSpPr>
+          <p:spPr>
+            <a:xfrm>
+              <a:off x="59187" y="16470"/>
+              <a:ext cx="242374" cy="215444"/>
+            </a:xfrm>
+            <a:prstGeom prst="rect">
+              <a:avLst/>
+            </a:prstGeom>
+            <a:noFill/>
+          </p:spPr>
+          <p:txBody>
+            <a:bodyPr wrap="none" rtlCol="0">
+              <a:spAutoFit/>
+            </a:bodyPr>
+            <a:lstStyle/>
+            <a:p>
+              <a:r>
+                <a:rPr lang="en-US" sz="800" b="1" dirty="0">
+                  <a:latin typeface="Arial" panose="020B0604020202020204" pitchFamily="34" charset="0"/>
+                  <a:cs typeface="Arial" panose="020B0604020202020204" pitchFamily="34" charset="0"/>
+                </a:rPr>
+                <a:t>a</a:t>
+              </a:r>
+            </a:p>
+          </p:txBody>
+        </p:sp>
+        <p:sp>
+          <p:nvSpPr>
+            <p:cNvPr id="23" name="TextBox 22">
+              <a:extLst>
+                <a:ext uri="{FF2B5EF4-FFF2-40B4-BE49-F238E27FC236}">
+                  <a16:creationId xmlns:a16="http://schemas.microsoft.com/office/drawing/2014/main" id="{751EA6F9-003A-3B7D-8F82-7ABCC356845E}"/>
+                </a:ext>
+              </a:extLst>
+            </p:cNvPr>
+            <p:cNvSpPr txBox="1"/>
+            <p:nvPr/>
+          </p:nvSpPr>
+          <p:spPr>
+            <a:xfrm>
+              <a:off x="4526720" y="12195"/>
+              <a:ext cx="247184" cy="215444"/>
+            </a:xfrm>
+            <a:prstGeom prst="rect">
+              <a:avLst/>
+            </a:prstGeom>
+            <a:noFill/>
+          </p:spPr>
+          <p:txBody>
+            <a:bodyPr wrap="none" rtlCol="0">
+              <a:spAutoFit/>
+            </a:bodyPr>
+            <a:lstStyle/>
+            <a:p>
+              <a:r>
+                <a:rPr lang="en-US" sz="800" b="1" dirty="0">
+                  <a:latin typeface="Arial" panose="020B0604020202020204" pitchFamily="34" charset="0"/>
+                  <a:cs typeface="Arial" panose="020B0604020202020204" pitchFamily="34" charset="0"/>
+                </a:rPr>
+                <a:t>b</a:t>
+              </a:r>
+            </a:p>
+          </p:txBody>
+        </p:sp>
+      </p:grpSp>
     </p:spTree>
     <p:extLst>
       <p:ext uri="{BB962C8B-B14F-4D97-AF65-F5344CB8AC3E}">

</xml_diff>